<commit_message>
docs: correct presentation positioning to accountability-layer narrative with measured evidence-tier data
Replace the "ANPR failure != tracking failure" headline (forbidden per
CLAUDE.md / DECISION_REVIEW_2026-09-11.md) with "The accountability layer
for Gujarat's existing CCTV estate". Slide 10 now shows real measured
evidence-tier counts (6 CONFIRMED, 4 PROBABLE, 12,251 LEAD_ONLY of 12,257)
instead of the unsupported differentiator claim. Model 3 status updated
from "roadmap" to "built & tested". Fixes a hardcoded machine-specific
output path.

Co-Authored-By: Claude Sonnet 5 <noreply@anthropic.com>
Claude-Session: https://claude.ai/code/session_019LT7gU1rJiSx8NpLPSPK9s
</commit_message>
<xml_diff>
--- a/docs/assets/Sentinel_Solution_Presentation.pptx
+++ b/docs/assets/Sentinel_Solution_Presentation.pptx
@@ -4116,7 +4116,7 @@
                 </a:solidFill>
                 <a:latin typeface="Segoe UI Semilight"/>
               </a:rPr>
-              <a:t>An open interoperability and intelligence layer for Gujarat's</a:t>
+              <a:t>The accountability layer for Gujarat's existing CCTV estate —</a:t>
             </a:r>
           </a:p>
           <a:p>
@@ -4135,7 +4135,7 @@
                 </a:solidFill>
                 <a:latin typeface="Segoe UI Semilight"/>
               </a:rPr>
-              <a:t>26-department CCTV infrastructure</a:t>
+              <a:t>not another detector, not a replacement VMS</a:t>
             </a:r>
           </a:p>
         </p:txBody>
@@ -4551,7 +4551,7 @@
                 </a:solidFill>
                 <a:latin typeface="Segoe UI Semibold"/>
               </a:rPr>
-              <a:t>CORE DIFFERENTIATOR</a:t>
+              <a:t>EVIDENCE TIERS</a:t>
             </a:r>
           </a:p>
         </p:txBody>
@@ -4593,7 +4593,7 @@
                 </a:solidFill>
                 <a:latin typeface="Bahnschrift SemiBold"/>
               </a:rPr>
-              <a:t>ANPR failure ≠ tracking failure</a:t>
+              <a:t>We measured our own weakest link — and refuse to hide it</a:t>
             </a:r>
           </a:p>
         </p:txBody>
@@ -4690,8 +4690,8 @@
         </p:nvSpPr>
         <p:spPr>
           <a:xfrm>
-            <a:off x="548640" y="1600200"/>
-            <a:ext cx="3429000" cy="2148840"/>
+            <a:off x="548640" y="1572768"/>
+            <a:ext cx="3520440" cy="2606040"/>
           </a:xfrm>
           <a:prstGeom prst="roundRect">
             <a:avLst>
@@ -4699,10 +4699,12 @@
             </a:avLst>
           </a:prstGeom>
           <a:solidFill>
-            <a:srgbClr val="F4F6FA"/>
-          </a:solidFill>
-          <a:ln>
-            <a:noFill/>
+            <a:srgbClr val="0D1628"/>
+          </a:solidFill>
+          <a:ln w="22225">
+            <a:solidFill>
+              <a:srgbClr val="12A16B"/>
+            </a:solidFill>
           </a:ln>
           <a:effectLst/>
         </p:spPr>
@@ -4730,58 +4732,14 @@
       </p:sp>
       <p:sp>
         <p:nvSpPr>
-          <p:cNvPr id="13" name="Oval 12"/>
-          <p:cNvSpPr/>
-          <p:nvPr/>
-        </p:nvSpPr>
-        <p:spPr>
-          <a:xfrm>
-            <a:off x="777240" y="1783079"/>
-            <a:ext cx="182880" cy="182880"/>
-          </a:xfrm>
-          <a:prstGeom prst="ellipse">
-            <a:avLst/>
-          </a:prstGeom>
-          <a:solidFill>
-            <a:srgbClr val="E04A4A"/>
-          </a:solidFill>
-          <a:ln>
-            <a:noFill/>
-          </a:ln>
-          <a:effectLst/>
-        </p:spPr>
-        <p:style>
-          <a:lnRef idx="1">
-            <a:schemeClr val="accent1"/>
-          </a:lnRef>
-          <a:fillRef idx="3">
-            <a:schemeClr val="accent1"/>
-          </a:fillRef>
-          <a:effectRef idx="2">
-            <a:schemeClr val="accent1"/>
-          </a:effectRef>
-          <a:fontRef idx="minor">
-            <a:schemeClr val="lt1"/>
-          </a:fontRef>
-        </p:style>
-        <p:txBody>
-          <a:bodyPr rtlCol="0" anchor="ctr"/>
-          <a:lstStyle/>
-          <a:p>
-            <a:pPr algn="ctr"/>
-          </a:p>
-        </p:txBody>
-      </p:sp>
-      <p:sp>
-        <p:nvSpPr>
-          <p:cNvPr id="14" name="TextBox 13"/>
+          <p:cNvPr id="13" name="TextBox 12"/>
           <p:cNvSpPr txBox="1"/>
           <p:nvPr/>
         </p:nvSpPr>
         <p:spPr>
           <a:xfrm>
-            <a:off x="1078992" y="1755648"/>
-            <a:ext cx="2697480" cy="320040"/>
+            <a:off x="804672" y="1755648"/>
+            <a:ext cx="3008376" cy="320040"/>
           </a:xfrm>
           <a:prstGeom prst="rect">
             <a:avLst/>
@@ -4803,27 +4761,27 @@
               </a:spcAft>
             </a:pPr>
             <a:r>
-              <a:rPr sz="1500" b="1" i="0">
-                <a:solidFill>
-                  <a:srgbClr val="111827"/>
+              <a:rPr sz="1450" b="1" i="0">
+                <a:solidFill>
+                  <a:srgbClr val="12A16B"/>
                 </a:solidFill>
                 <a:latin typeface="Segoe UI Semibold"/>
               </a:rPr>
-              <a:t>Camera 1</a:t>
-            </a:r>
-          </a:p>
-        </p:txBody>
-      </p:sp>
-      <p:sp>
-        <p:nvSpPr>
-          <p:cNvPr id="15" name="TextBox 14"/>
+              <a:t>CONFIRMED</a:t>
+            </a:r>
+          </a:p>
+        </p:txBody>
+      </p:sp>
+      <p:sp>
+        <p:nvSpPr>
+          <p:cNvPr id="14" name="TextBox 13"/>
           <p:cNvSpPr txBox="1"/>
           <p:nvPr/>
         </p:nvSpPr>
         <p:spPr>
           <a:xfrm>
-            <a:off x="822960" y="2286000"/>
-            <a:ext cx="2880360" cy="457200"/>
+            <a:off x="804672" y="2084831"/>
+            <a:ext cx="3008376" cy="685800"/>
           </a:xfrm>
           <a:prstGeom prst="rect">
             <a:avLst/>
@@ -4845,201 +4803,27 @@
               </a:spcAft>
             </a:pPr>
             <a:r>
-              <a:rPr sz="1550" b="1" i="0">
-                <a:solidFill>
-                  <a:srgbClr val="616E82"/>
-                </a:solidFill>
-                <a:latin typeface="Segoe UI Semibold"/>
-              </a:rPr>
-              <a:t>Plate unreadable</a:t>
-            </a:r>
-          </a:p>
-        </p:txBody>
-      </p:sp>
-      <p:sp>
-        <p:nvSpPr>
-          <p:cNvPr id="16" name="TextBox 15"/>
+              <a:rPr sz="3400" b="1" i="0">
+                <a:solidFill>
+                  <a:srgbClr val="FFFFFF"/>
+                </a:solidFill>
+                <a:latin typeface="Bahnschrift SemiBold"/>
+              </a:rPr>
+              <a:t>6</a:t>
+            </a:r>
+          </a:p>
+        </p:txBody>
+      </p:sp>
+      <p:sp>
+        <p:nvSpPr>
+          <p:cNvPr id="15" name="TextBox 14"/>
           <p:cNvSpPr txBox="1"/>
           <p:nvPr/>
         </p:nvSpPr>
         <p:spPr>
           <a:xfrm>
-            <a:off x="822960" y="2834640"/>
-            <a:ext cx="2880360" cy="777240"/>
-          </a:xfrm>
-          <a:prstGeom prst="rect">
-            <a:avLst/>
-          </a:prstGeom>
-          <a:noFill/>
-        </p:spPr>
-        <p:txBody>
-          <a:bodyPr wrap="square" anchor="t" lIns="0" rIns="0" tIns="0" bIns="0">
-            <a:spAutoFit/>
-          </a:bodyPr>
-          <a:lstStyle/>
-          <a:p>
-            <a:pPr algn="l">
-              <a:lnSpc>
-                <a:spcPct val="120000"/>
-              </a:lnSpc>
-              <a:spcAft>
-                <a:spcPts val="0"/>
-              </a:spcAft>
-            </a:pPr>
-            <a:r>
-              <a:rPr sz="1150" b="0" i="0">
-                <a:solidFill>
-                  <a:srgbClr val="616E82"/>
-                </a:solidFill>
-                <a:latin typeface="Segoe UI Semilight"/>
-              </a:rPr>
-              <a:t>Logged by colour + type + appearance</a:t>
-            </a:r>
-          </a:p>
-        </p:txBody>
-      </p:sp>
-      <p:sp>
-        <p:nvSpPr>
-          <p:cNvPr id="17" name="TextBox 16"/>
-          <p:cNvSpPr txBox="1"/>
-          <p:nvPr/>
-        </p:nvSpPr>
-        <p:spPr>
-          <a:xfrm>
-            <a:off x="3995928" y="2423160"/>
-            <a:ext cx="320040" cy="457200"/>
-          </a:xfrm>
-          <a:prstGeom prst="rect">
-            <a:avLst/>
-          </a:prstGeom>
-          <a:noFill/>
-        </p:spPr>
-        <p:txBody>
-          <a:bodyPr wrap="square" anchor="t" lIns="0" rIns="0" tIns="0" bIns="0">
-            <a:spAutoFit/>
-          </a:bodyPr>
-          <a:lstStyle/>
-          <a:p>
-            <a:pPr algn="ctr">
-              <a:lnSpc>
-                <a:spcPct val="100000"/>
-              </a:lnSpc>
-              <a:spcAft>
-                <a:spcPts val="0"/>
-              </a:spcAft>
-            </a:pPr>
-            <a:r>
-              <a:rPr sz="2600" b="1" i="0">
-                <a:solidFill>
-                  <a:srgbClr val="2F7AF2"/>
-                </a:solidFill>
-                <a:latin typeface="Segoe UI"/>
-              </a:rPr>
-              <a:t>→</a:t>
-            </a:r>
-          </a:p>
-        </p:txBody>
-      </p:sp>
-      <p:sp>
-        <p:nvSpPr>
-          <p:cNvPr id="18" name="Rounded Rectangle 17"/>
-          <p:cNvSpPr/>
-          <p:nvPr/>
-        </p:nvSpPr>
-        <p:spPr>
-          <a:xfrm>
-            <a:off x="4297680" y="1600200"/>
-            <a:ext cx="3429000" cy="2148840"/>
-          </a:xfrm>
-          <a:prstGeom prst="roundRect">
-            <a:avLst>
-              <a:gd name="adj" fmla="val 8000"/>
-            </a:avLst>
-          </a:prstGeom>
-          <a:solidFill>
-            <a:srgbClr val="F4F6FA"/>
-          </a:solidFill>
-          <a:ln>
-            <a:noFill/>
-          </a:ln>
-          <a:effectLst/>
-        </p:spPr>
-        <p:style>
-          <a:lnRef idx="1">
-            <a:schemeClr val="accent1"/>
-          </a:lnRef>
-          <a:fillRef idx="3">
-            <a:schemeClr val="accent1"/>
-          </a:fillRef>
-          <a:effectRef idx="2">
-            <a:schemeClr val="accent1"/>
-          </a:effectRef>
-          <a:fontRef idx="minor">
-            <a:schemeClr val="lt1"/>
-          </a:fontRef>
-        </p:style>
-        <p:txBody>
-          <a:bodyPr rtlCol="0" anchor="ctr"/>
-          <a:lstStyle/>
-          <a:p>
-            <a:pPr algn="ctr"/>
-          </a:p>
-        </p:txBody>
-      </p:sp>
-      <p:sp>
-        <p:nvSpPr>
-          <p:cNvPr id="19" name="Oval 18"/>
-          <p:cNvSpPr/>
-          <p:nvPr/>
-        </p:nvSpPr>
-        <p:spPr>
-          <a:xfrm>
-            <a:off x="4526280" y="1783079"/>
-            <a:ext cx="182880" cy="182880"/>
-          </a:xfrm>
-          <a:prstGeom prst="ellipse">
-            <a:avLst/>
-          </a:prstGeom>
-          <a:solidFill>
-            <a:srgbClr val="E04A4A"/>
-          </a:solidFill>
-          <a:ln>
-            <a:noFill/>
-          </a:ln>
-          <a:effectLst/>
-        </p:spPr>
-        <p:style>
-          <a:lnRef idx="1">
-            <a:schemeClr val="accent1"/>
-          </a:lnRef>
-          <a:fillRef idx="3">
-            <a:schemeClr val="accent1"/>
-          </a:fillRef>
-          <a:effectRef idx="2">
-            <a:schemeClr val="accent1"/>
-          </a:effectRef>
-          <a:fontRef idx="minor">
-            <a:schemeClr val="lt1"/>
-          </a:fontRef>
-        </p:style>
-        <p:txBody>
-          <a:bodyPr rtlCol="0" anchor="ctr"/>
-          <a:lstStyle/>
-          <a:p>
-            <a:pPr algn="ctr"/>
-          </a:p>
-        </p:txBody>
-      </p:sp>
-      <p:sp>
-        <p:nvSpPr>
-          <p:cNvPr id="20" name="TextBox 19"/>
-          <p:cNvSpPr txBox="1"/>
-          <p:nvPr/>
-        </p:nvSpPr>
-        <p:spPr>
-          <a:xfrm>
-            <a:off x="4828032" y="1755648"/>
-            <a:ext cx="2697480" cy="320040"/>
+            <a:off x="804672" y="2743200"/>
+            <a:ext cx="3008376" cy="320040"/>
           </a:xfrm>
           <a:prstGeom prst="rect">
             <a:avLst/>
@@ -5061,27 +4845,117 @@
               </a:spcAft>
             </a:pPr>
             <a:r>
-              <a:rPr sz="1500" b="1" i="0">
-                <a:solidFill>
-                  <a:srgbClr val="111827"/>
-                </a:solidFill>
-                <a:latin typeface="Segoe UI Semibold"/>
-              </a:rPr>
-              <a:t>Camera 2</a:t>
-            </a:r>
-          </a:p>
-        </p:txBody>
-      </p:sp>
-      <p:sp>
-        <p:nvSpPr>
-          <p:cNvPr id="21" name="TextBox 20"/>
+              <a:rPr sz="1100" b="0" i="0">
+                <a:solidFill>
+                  <a:srgbClr val="8A96A8"/>
+                </a:solidFill>
+                <a:latin typeface="Segoe UI Semilight"/>
+              </a:rPr>
+              <a:t>of 12,257 events</a:t>
+            </a:r>
+          </a:p>
+        </p:txBody>
+      </p:sp>
+      <p:sp>
+        <p:nvSpPr>
+          <p:cNvPr id="16" name="TextBox 15"/>
           <p:cNvSpPr txBox="1"/>
           <p:nvPr/>
         </p:nvSpPr>
         <p:spPr>
           <a:xfrm>
-            <a:off x="4572000" y="2286000"/>
-            <a:ext cx="2880360" cy="457200"/>
+            <a:off x="804672" y="3127248"/>
+            <a:ext cx="3008376" cy="960120"/>
+          </a:xfrm>
+          <a:prstGeom prst="rect">
+            <a:avLst/>
+          </a:prstGeom>
+          <a:noFill/>
+        </p:spPr>
+        <p:txBody>
+          <a:bodyPr wrap="square" anchor="t" lIns="0" rIns="0" tIns="0" bIns="0">
+            <a:spAutoFit/>
+          </a:bodyPr>
+          <a:lstStyle/>
+          <a:p>
+            <a:pPr algn="l">
+              <a:lnSpc>
+                <a:spcPct val="125000"/>
+              </a:lnSpc>
+              <a:spcAft>
+                <a:spcPts val="0"/>
+              </a:spcAft>
+            </a:pPr>
+            <a:r>
+              <a:rPr sz="1150" b="0" i="0">
+                <a:solidFill>
+                  <a:srgbClr val="C7D3E3"/>
+                </a:solidFill>
+                <a:latin typeface="Segoe UI Semilight"/>
+              </a:rPr>
+              <a:t>This sighting read and validated its own plate.</a:t>
+            </a:r>
+          </a:p>
+        </p:txBody>
+      </p:sp>
+      <p:sp>
+        <p:nvSpPr>
+          <p:cNvPr id="17" name="Rounded Rectangle 16"/>
+          <p:cNvSpPr/>
+          <p:nvPr/>
+        </p:nvSpPr>
+        <p:spPr>
+          <a:xfrm>
+            <a:off x="4251960" y="1572768"/>
+            <a:ext cx="3520440" cy="2606040"/>
+          </a:xfrm>
+          <a:prstGeom prst="roundRect">
+            <a:avLst>
+              <a:gd name="adj" fmla="val 8000"/>
+            </a:avLst>
+          </a:prstGeom>
+          <a:solidFill>
+            <a:srgbClr val="0D1628"/>
+          </a:solidFill>
+          <a:ln w="22225">
+            <a:solidFill>
+              <a:srgbClr val="F29A1E"/>
+            </a:solidFill>
+          </a:ln>
+          <a:effectLst/>
+        </p:spPr>
+        <p:style>
+          <a:lnRef idx="1">
+            <a:schemeClr val="accent1"/>
+          </a:lnRef>
+          <a:fillRef idx="3">
+            <a:schemeClr val="accent1"/>
+          </a:fillRef>
+          <a:effectRef idx="2">
+            <a:schemeClr val="accent1"/>
+          </a:effectRef>
+          <a:fontRef idx="minor">
+            <a:schemeClr val="lt1"/>
+          </a:fontRef>
+        </p:style>
+        <p:txBody>
+          <a:bodyPr rtlCol="0" anchor="ctr"/>
+          <a:lstStyle/>
+          <a:p>
+            <a:pPr algn="ctr"/>
+          </a:p>
+        </p:txBody>
+      </p:sp>
+      <p:sp>
+        <p:nvSpPr>
+          <p:cNvPr id="18" name="TextBox 17"/>
+          <p:cNvSpPr txBox="1"/>
+          <p:nvPr/>
+        </p:nvSpPr>
+        <p:spPr>
+          <a:xfrm>
+            <a:off x="4507992" y="1755648"/>
+            <a:ext cx="3008376" cy="320040"/>
           </a:xfrm>
           <a:prstGeom prst="rect">
             <a:avLst/>
@@ -5103,201 +4977,27 @@
               </a:spcAft>
             </a:pPr>
             <a:r>
-              <a:rPr sz="1550" b="1" i="0">
-                <a:solidFill>
-                  <a:srgbClr val="616E82"/>
+              <a:rPr sz="1450" b="1" i="0">
+                <a:solidFill>
+                  <a:srgbClr val="F29A1E"/>
                 </a:solidFill>
                 <a:latin typeface="Segoe UI Semibold"/>
               </a:rPr>
-              <a:t>Plate unreadable</a:t>
-            </a:r>
-          </a:p>
-        </p:txBody>
-      </p:sp>
-      <p:sp>
-        <p:nvSpPr>
-          <p:cNvPr id="22" name="TextBox 21"/>
+              <a:t>PROBABLE</a:t>
+            </a:r>
+          </a:p>
+        </p:txBody>
+      </p:sp>
+      <p:sp>
+        <p:nvSpPr>
+          <p:cNvPr id="19" name="TextBox 18"/>
           <p:cNvSpPr txBox="1"/>
           <p:nvPr/>
         </p:nvSpPr>
         <p:spPr>
           <a:xfrm>
-            <a:off x="4572000" y="2834640"/>
-            <a:ext cx="2880360" cy="777240"/>
-          </a:xfrm>
-          <a:prstGeom prst="rect">
-            <a:avLst/>
-          </a:prstGeom>
-          <a:noFill/>
-        </p:spPr>
-        <p:txBody>
-          <a:bodyPr wrap="square" anchor="t" lIns="0" rIns="0" tIns="0" bIns="0">
-            <a:spAutoFit/>
-          </a:bodyPr>
-          <a:lstStyle/>
-          <a:p>
-            <a:pPr algn="l">
-              <a:lnSpc>
-                <a:spcPct val="120000"/>
-              </a:lnSpc>
-              <a:spcAft>
-                <a:spcPts val="0"/>
-              </a:spcAft>
-            </a:pPr>
-            <a:r>
-              <a:rPr sz="1150" b="0" i="0">
-                <a:solidFill>
-                  <a:srgbClr val="616E82"/>
-                </a:solidFill>
-                <a:latin typeface="Segoe UI Semilight"/>
-              </a:rPr>
-              <a:t>Logged by colour + type + appearance</a:t>
-            </a:r>
-          </a:p>
-        </p:txBody>
-      </p:sp>
-      <p:sp>
-        <p:nvSpPr>
-          <p:cNvPr id="23" name="TextBox 22"/>
-          <p:cNvSpPr txBox="1"/>
-          <p:nvPr/>
-        </p:nvSpPr>
-        <p:spPr>
-          <a:xfrm>
-            <a:off x="7744968" y="2423160"/>
-            <a:ext cx="320040" cy="457200"/>
-          </a:xfrm>
-          <a:prstGeom prst="rect">
-            <a:avLst/>
-          </a:prstGeom>
-          <a:noFill/>
-        </p:spPr>
-        <p:txBody>
-          <a:bodyPr wrap="square" anchor="t" lIns="0" rIns="0" tIns="0" bIns="0">
-            <a:spAutoFit/>
-          </a:bodyPr>
-          <a:lstStyle/>
-          <a:p>
-            <a:pPr algn="ctr">
-              <a:lnSpc>
-                <a:spcPct val="100000"/>
-              </a:lnSpc>
-              <a:spcAft>
-                <a:spcPts val="0"/>
-              </a:spcAft>
-            </a:pPr>
-            <a:r>
-              <a:rPr sz="2600" b="1" i="0">
-                <a:solidFill>
-                  <a:srgbClr val="2F7AF2"/>
-                </a:solidFill>
-                <a:latin typeface="Segoe UI"/>
-              </a:rPr>
-              <a:t>→</a:t>
-            </a:r>
-          </a:p>
-        </p:txBody>
-      </p:sp>
-      <p:sp>
-        <p:nvSpPr>
-          <p:cNvPr id="24" name="Rounded Rectangle 23"/>
-          <p:cNvSpPr/>
-          <p:nvPr/>
-        </p:nvSpPr>
-        <p:spPr>
-          <a:xfrm>
-            <a:off x="8046720" y="1600200"/>
-            <a:ext cx="3429000" cy="2148840"/>
-          </a:xfrm>
-          <a:prstGeom prst="roundRect">
-            <a:avLst>
-              <a:gd name="adj" fmla="val 8000"/>
-            </a:avLst>
-          </a:prstGeom>
-          <a:solidFill>
-            <a:srgbClr val="0E281C"/>
-          </a:solidFill>
-          <a:ln>
-            <a:noFill/>
-          </a:ln>
-          <a:effectLst/>
-        </p:spPr>
-        <p:style>
-          <a:lnRef idx="1">
-            <a:schemeClr val="accent1"/>
-          </a:lnRef>
-          <a:fillRef idx="3">
-            <a:schemeClr val="accent1"/>
-          </a:fillRef>
-          <a:effectRef idx="2">
-            <a:schemeClr val="accent1"/>
-          </a:effectRef>
-          <a:fontRef idx="minor">
-            <a:schemeClr val="lt1"/>
-          </a:fontRef>
-        </p:style>
-        <p:txBody>
-          <a:bodyPr rtlCol="0" anchor="ctr"/>
-          <a:lstStyle/>
-          <a:p>
-            <a:pPr algn="ctr"/>
-          </a:p>
-        </p:txBody>
-      </p:sp>
-      <p:sp>
-        <p:nvSpPr>
-          <p:cNvPr id="25" name="Oval 24"/>
-          <p:cNvSpPr/>
-          <p:nvPr/>
-        </p:nvSpPr>
-        <p:spPr>
-          <a:xfrm>
-            <a:off x="8275320" y="1783079"/>
-            <a:ext cx="182880" cy="182880"/>
-          </a:xfrm>
-          <a:prstGeom prst="ellipse">
-            <a:avLst/>
-          </a:prstGeom>
-          <a:solidFill>
-            <a:srgbClr val="12A16B"/>
-          </a:solidFill>
-          <a:ln>
-            <a:noFill/>
-          </a:ln>
-          <a:effectLst/>
-        </p:spPr>
-        <p:style>
-          <a:lnRef idx="1">
-            <a:schemeClr val="accent1"/>
-          </a:lnRef>
-          <a:fillRef idx="3">
-            <a:schemeClr val="accent1"/>
-          </a:fillRef>
-          <a:effectRef idx="2">
-            <a:schemeClr val="accent1"/>
-          </a:effectRef>
-          <a:fontRef idx="minor">
-            <a:schemeClr val="lt1"/>
-          </a:fontRef>
-        </p:style>
-        <p:txBody>
-          <a:bodyPr rtlCol="0" anchor="ctr"/>
-          <a:lstStyle/>
-          <a:p>
-            <a:pPr algn="ctr"/>
-          </a:p>
-        </p:txBody>
-      </p:sp>
-      <p:sp>
-        <p:nvSpPr>
-          <p:cNvPr id="26" name="TextBox 25"/>
-          <p:cNvSpPr txBox="1"/>
-          <p:nvPr/>
-        </p:nvSpPr>
-        <p:spPr>
-          <a:xfrm>
-            <a:off x="8577072" y="1755648"/>
-            <a:ext cx="2697480" cy="320040"/>
+            <a:off x="4507992" y="2084831"/>
+            <a:ext cx="3008376" cy="685800"/>
           </a:xfrm>
           <a:prstGeom prst="rect">
             <a:avLst/>
@@ -5319,27 +5019,27 @@
               </a:spcAft>
             </a:pPr>
             <a:r>
-              <a:rPr sz="1500" b="1" i="0">
+              <a:rPr sz="3400" b="1" i="0">
                 <a:solidFill>
                   <a:srgbClr val="FFFFFF"/>
                 </a:solidFill>
-                <a:latin typeface="Segoe UI Semibold"/>
-              </a:rPr>
-              <a:t>Camera 3</a:t>
-            </a:r>
-          </a:p>
-        </p:txBody>
-      </p:sp>
-      <p:sp>
-        <p:nvSpPr>
-          <p:cNvPr id="27" name="TextBox 26"/>
+                <a:latin typeface="Bahnschrift SemiBold"/>
+              </a:rPr>
+              <a:t>4</a:t>
+            </a:r>
+          </a:p>
+        </p:txBody>
+      </p:sp>
+      <p:sp>
+        <p:nvSpPr>
+          <p:cNvPr id="20" name="TextBox 19"/>
           <p:cNvSpPr txBox="1"/>
           <p:nvPr/>
         </p:nvSpPr>
         <p:spPr>
           <a:xfrm>
-            <a:off x="8321040" y="2286000"/>
-            <a:ext cx="2880360" cy="457200"/>
+            <a:off x="4507992" y="2743200"/>
+            <a:ext cx="3008376" cy="320040"/>
           </a:xfrm>
           <a:prstGeom prst="rect">
             <a:avLst/>
@@ -5361,27 +5061,27 @@
               </a:spcAft>
             </a:pPr>
             <a:r>
-              <a:rPr sz="1550" b="1" i="0">
-                <a:solidFill>
-                  <a:srgbClr val="1EC9B7"/>
-                </a:solidFill>
-                <a:latin typeface="Segoe UI Semibold"/>
-              </a:rPr>
-              <a:t>GJ01AB1234 read</a:t>
-            </a:r>
-          </a:p>
-        </p:txBody>
-      </p:sp>
-      <p:sp>
-        <p:nvSpPr>
-          <p:cNvPr id="28" name="TextBox 27"/>
+              <a:rPr sz="1100" b="0" i="0">
+                <a:solidFill>
+                  <a:srgbClr val="8A96A8"/>
+                </a:solidFill>
+                <a:latin typeface="Segoe UI Semilight"/>
+              </a:rPr>
+              <a:t>plate_upgrade links</a:t>
+            </a:r>
+          </a:p>
+        </p:txBody>
+      </p:sp>
+      <p:sp>
+        <p:nvSpPr>
+          <p:cNvPr id="21" name="TextBox 20"/>
           <p:cNvSpPr txBox="1"/>
           <p:nvPr/>
         </p:nvSpPr>
         <p:spPr>
           <a:xfrm>
-            <a:off x="8321040" y="2834640"/>
-            <a:ext cx="2880360" cy="777240"/>
+            <a:off x="4507992" y="3127248"/>
+            <a:ext cx="3008376" cy="960120"/>
           </a:xfrm>
           <a:prstGeom prst="rect">
             <a:avLst/>
@@ -5396,7 +5096,7 @@
           <a:p>
             <a:pPr algn="l">
               <a:lnSpc>
-                <a:spcPct val="120000"/>
+                <a:spcPct val="125000"/>
               </a:lnSpc>
               <a:spcAft>
                 <a:spcPts val="0"/>
@@ -5405,24 +5105,282 @@
             <a:r>
               <a:rPr sz="1150" b="0" i="0">
                 <a:solidFill>
-                  <a:srgbClr val="C9E9DE"/>
+                  <a:srgbClr val="C7D3E3"/>
                 </a:solidFill>
                 <a:latin typeface="Segoe UI Semilight"/>
               </a:rPr>
-              <a:t>Whole chain resolves — retroactively</a:t>
-            </a:r>
-          </a:p>
-        </p:txBody>
-      </p:sp>
-      <p:sp>
-        <p:nvSpPr>
-          <p:cNvPr id="29" name="TextBox 28"/>
+              <a:t>No plate here, but linked by within-camera track continuity from one that read.</a:t>
+            </a:r>
+          </a:p>
+        </p:txBody>
+      </p:sp>
+      <p:sp>
+        <p:nvSpPr>
+          <p:cNvPr id="22" name="Rounded Rectangle 21"/>
+          <p:cNvSpPr/>
+          <p:nvPr/>
+        </p:nvSpPr>
+        <p:spPr>
+          <a:xfrm>
+            <a:off x="7955280" y="1572768"/>
+            <a:ext cx="3520440" cy="2606040"/>
+          </a:xfrm>
+          <a:prstGeom prst="roundRect">
+            <a:avLst>
+              <a:gd name="adj" fmla="val 8000"/>
+            </a:avLst>
+          </a:prstGeom>
+          <a:solidFill>
+            <a:srgbClr val="0D1628"/>
+          </a:solidFill>
+          <a:ln w="22225">
+            <a:solidFill>
+              <a:srgbClr val="E04A4A"/>
+            </a:solidFill>
+          </a:ln>
+          <a:effectLst/>
+        </p:spPr>
+        <p:style>
+          <a:lnRef idx="1">
+            <a:schemeClr val="accent1"/>
+          </a:lnRef>
+          <a:fillRef idx="3">
+            <a:schemeClr val="accent1"/>
+          </a:fillRef>
+          <a:effectRef idx="2">
+            <a:schemeClr val="accent1"/>
+          </a:effectRef>
+          <a:fontRef idx="minor">
+            <a:schemeClr val="lt1"/>
+          </a:fontRef>
+        </p:style>
+        <p:txBody>
+          <a:bodyPr rtlCol="0" anchor="ctr"/>
+          <a:lstStyle/>
+          <a:p>
+            <a:pPr algn="ctr"/>
+          </a:p>
+        </p:txBody>
+      </p:sp>
+      <p:sp>
+        <p:nvSpPr>
+          <p:cNvPr id="23" name="TextBox 22"/>
           <p:cNvSpPr txBox="1"/>
           <p:nvPr/>
         </p:nvSpPr>
         <p:spPr>
           <a:xfrm>
-            <a:off x="548640" y="4114800"/>
+            <a:off x="8211312" y="1755648"/>
+            <a:ext cx="3008376" cy="320040"/>
+          </a:xfrm>
+          <a:prstGeom prst="rect">
+            <a:avLst/>
+          </a:prstGeom>
+          <a:noFill/>
+        </p:spPr>
+        <p:txBody>
+          <a:bodyPr wrap="square" anchor="t" lIns="0" rIns="0" tIns="0" bIns="0">
+            <a:spAutoFit/>
+          </a:bodyPr>
+          <a:lstStyle/>
+          <a:p>
+            <a:pPr algn="l">
+              <a:lnSpc>
+                <a:spcPct val="100000"/>
+              </a:lnSpc>
+              <a:spcAft>
+                <a:spcPts val="0"/>
+              </a:spcAft>
+            </a:pPr>
+            <a:r>
+              <a:rPr sz="1450" b="1" i="0">
+                <a:solidFill>
+                  <a:srgbClr val="E04A4A"/>
+                </a:solidFill>
+                <a:latin typeface="Segoe UI Semibold"/>
+              </a:rPr>
+              <a:t>LEAD ONLY</a:t>
+            </a:r>
+          </a:p>
+        </p:txBody>
+      </p:sp>
+      <p:sp>
+        <p:nvSpPr>
+          <p:cNvPr id="24" name="TextBox 23"/>
+          <p:cNvSpPr txBox="1"/>
+          <p:nvPr/>
+        </p:nvSpPr>
+        <p:spPr>
+          <a:xfrm>
+            <a:off x="8211312" y="2084831"/>
+            <a:ext cx="3008376" cy="685800"/>
+          </a:xfrm>
+          <a:prstGeom prst="rect">
+            <a:avLst/>
+          </a:prstGeom>
+          <a:noFill/>
+        </p:spPr>
+        <p:txBody>
+          <a:bodyPr wrap="square" anchor="t" lIns="0" rIns="0" tIns="0" bIns="0">
+            <a:spAutoFit/>
+          </a:bodyPr>
+          <a:lstStyle/>
+          <a:p>
+            <a:pPr algn="l">
+              <a:lnSpc>
+                <a:spcPct val="100000"/>
+              </a:lnSpc>
+              <a:spcAft>
+                <a:spcPts val="0"/>
+              </a:spcAft>
+            </a:pPr>
+            <a:r>
+              <a:rPr sz="3400" b="1" i="0">
+                <a:solidFill>
+                  <a:srgbClr val="FFFFFF"/>
+                </a:solidFill>
+                <a:latin typeface="Bahnschrift SemiBold"/>
+              </a:rPr>
+              <a:t>12,251</a:t>
+            </a:r>
+          </a:p>
+        </p:txBody>
+      </p:sp>
+      <p:sp>
+        <p:nvSpPr>
+          <p:cNvPr id="25" name="TextBox 24"/>
+          <p:cNvSpPr txBox="1"/>
+          <p:nvPr/>
+        </p:nvSpPr>
+        <p:spPr>
+          <a:xfrm>
+            <a:off x="8211312" y="2743200"/>
+            <a:ext cx="3008376" cy="320040"/>
+          </a:xfrm>
+          <a:prstGeom prst="rect">
+            <a:avLst/>
+          </a:prstGeom>
+          <a:noFill/>
+        </p:spPr>
+        <p:txBody>
+          <a:bodyPr wrap="square" anchor="t" lIns="0" rIns="0" tIns="0" bIns="0">
+            <a:spAutoFit/>
+          </a:bodyPr>
+          <a:lstStyle/>
+          <a:p>
+            <a:pPr algn="l">
+              <a:lnSpc>
+                <a:spcPct val="100000"/>
+              </a:lnSpc>
+              <a:spcAft>
+                <a:spcPts val="0"/>
+              </a:spcAft>
+            </a:pPr>
+            <a:r>
+              <a:rPr sz="1100" b="0" i="0">
+                <a:solidFill>
+                  <a:srgbClr val="8A96A8"/>
+                </a:solidFill>
+                <a:latin typeface="Segoe UI Semilight"/>
+              </a:rPr>
+              <a:t>appearance-only or anonymous</a:t>
+            </a:r>
+          </a:p>
+        </p:txBody>
+      </p:sp>
+      <p:sp>
+        <p:nvSpPr>
+          <p:cNvPr id="26" name="TextBox 25"/>
+          <p:cNvSpPr txBox="1"/>
+          <p:nvPr/>
+        </p:nvSpPr>
+        <p:spPr>
+          <a:xfrm>
+            <a:off x="8211312" y="3127248"/>
+            <a:ext cx="3008376" cy="960120"/>
+          </a:xfrm>
+          <a:prstGeom prst="rect">
+            <a:avLst/>
+          </a:prstGeom>
+          <a:noFill/>
+        </p:spPr>
+        <p:txBody>
+          <a:bodyPr wrap="square" anchor="t" lIns="0" rIns="0" tIns="0" bIns="0">
+            <a:spAutoFit/>
+          </a:bodyPr>
+          <a:lstStyle/>
+          <a:p>
+            <a:pPr algn="l">
+              <a:lnSpc>
+                <a:spcPct val="125000"/>
+              </a:lnSpc>
+              <a:spcAft>
+                <a:spcPts val="0"/>
+              </a:spcAft>
+            </a:pPr>
+            <a:r>
+              <a:rPr sz="1150" b="0" i="0">
+                <a:solidFill>
+                  <a:srgbClr val="C7D3E3"/>
+                </a:solidFill>
+                <a:latin typeface="Segoe UI Semilight"/>
+              </a:rPr>
+              <a:t>41.87% measured false-positive rate. Not exportable as evidence.</a:t>
+            </a:r>
+          </a:p>
+        </p:txBody>
+      </p:sp>
+      <p:sp>
+        <p:nvSpPr>
+          <p:cNvPr id="27" name="TextBox 26"/>
+          <p:cNvSpPr txBox="1"/>
+          <p:nvPr/>
+        </p:nvSpPr>
+        <p:spPr>
+          <a:xfrm>
+            <a:off x="548640" y="4434840"/>
+            <a:ext cx="11064240" cy="365760"/>
+          </a:xfrm>
+          <a:prstGeom prst="rect">
+            <a:avLst/>
+          </a:prstGeom>
+          <a:noFill/>
+        </p:spPr>
+        <p:txBody>
+          <a:bodyPr wrap="square" anchor="t" lIns="0" rIns="0" tIns="0" bIns="0">
+            <a:spAutoFit/>
+          </a:bodyPr>
+          <a:lstStyle/>
+          <a:p>
+            <a:pPr algn="l">
+              <a:lnSpc>
+                <a:spcPct val="100000"/>
+              </a:lnSpc>
+              <a:spcAft>
+                <a:spcPts val="0"/>
+              </a:spcAft>
+            </a:pPr>
+            <a:r>
+              <a:rPr sz="1350" b="1" i="0">
+                <a:solidFill>
+                  <a:srgbClr val="0D1628"/>
+                </a:solidFill>
+                <a:latin typeface="Segoe UI Semibold"/>
+              </a:rPr>
+              <a:t>Only CONFIRMED is exportable. PROBABLE is deliberately excluded too — an export is where a hedge stops being visible.</a:t>
+            </a:r>
+          </a:p>
+        </p:txBody>
+      </p:sp>
+      <p:sp>
+        <p:nvSpPr>
+          <p:cNvPr id="28" name="TextBox 27"/>
+          <p:cNvSpPr txBox="1"/>
+          <p:nvPr/>
+        </p:nvSpPr>
+        <p:spPr>
+          <a:xfrm>
+            <a:off x="548640" y="4937760"/>
             <a:ext cx="11064240" cy="1280160"/>
           </a:xfrm>
           <a:prstGeom prst="rect">
@@ -5445,13 +5403,13 @@
               </a:spcAft>
             </a:pPr>
             <a:r>
-              <a:rPr sz="1550" b="0" i="0">
+              <a:rPr sz="1350" b="0" i="0">
                 <a:solidFill>
                   <a:srgbClr val="111827"/>
                 </a:solidFill>
                 <a:latin typeface="Segoe UI Semilight"/>
               </a:rPr>
-              <a:t>Verified with a real, non-mocked scenario: two unreadable plates, one successful read — all three sightings merge into one identity, including the two anonymous ones.</a:t>
+              <a:t>Real query over the live sentinel.db, not a projection. The appearance encoder carrying 97.8% of cross-camera links is a colour-histogram model we ourselves measured at a 41.87% false-positive rate on real confirmed-different-vehicle pairs — so the system labels that class LEAD ONLY and blocks its export, rather than presenting it as a tracked vehicle.</a:t>
             </a:r>
           </a:p>
         </p:txBody>
@@ -5783,7 +5741,7 @@
                 </a:solidFill>
                 <a:latin typeface="Segoe UI Semibold"/>
               </a:rPr>
-              <a:t>BONUS DIFFERENTIATOR</a:t>
+              <a:t>GOVERNED CROSS-CAMERA LINKING</a:t>
             </a:r>
           </a:p>
         </p:txBody>
@@ -6879,13 +6837,13 @@
               </a:spcAft>
             </a:pPr>
             <a:r>
-              <a:rPr sz="1450" b="0" i="0">
+              <a:rPr sz="1350" b="0" i="0">
                 <a:solidFill>
                   <a:srgbClr val="616E82"/>
                 </a:solidFill>
                 <a:latin typeface="Segoe UI Semilight"/>
               </a:rPr>
-              <a:t>Straight-line distance + time-gap feasibility between confirmed sightings — a lead, never presented as fact. A high implied speed flags “not a direct drive.”</a:t>
+              <a:t>Straight-line distance + time-gap feasibility between sightings — a lead, never presented as fact. A high implied speed flags “not a direct drive.” Appearance-only links carry the same discipline: labelled LEAD ONLY, shown with their score, and never silently upgraded to CONFIRMED.</a:t>
             </a:r>
           </a:p>
         </p:txBody>
@@ -13526,13 +13484,13 @@
               </a:spcAft>
             </a:pPr>
             <a:r>
-              <a:rPr sz="1400" b="0" i="1">
+              <a:rPr sz="1300" b="0" i="1">
                 <a:solidFill>
                   <a:srgbClr val="616E82"/>
                 </a:solidFill>
                 <a:latin typeface="Segoe UI Semilight"/>
               </a:rPr>
-              <a:t>Same codebase at every phase — pilot, district, regional, statewide. Nothing here is a throwaway demo architecture.</a:t>
+              <a:t>Same codebase at every phase — pilot, district, regional, statewide. The 80,000-camera figures above are arithmetic projections from the ~30-camera pilot's measured per-stream cost, not a proven statewide result.</a:t>
             </a:r>
           </a:p>
         </p:txBody>
@@ -14716,7 +14674,7 @@
             <a:avLst/>
           </a:prstGeom>
           <a:solidFill>
-            <a:srgbClr val="12A16B"/>
+            <a:srgbClr val="F29A1E"/>
           </a:solidFill>
           <a:ln>
             <a:noFill/>
@@ -14782,7 +14740,7 @@
                 </a:solidFill>
                 <a:latin typeface="Segoe UI Semibold"/>
               </a:rPr>
-              <a:t>Continuity w/o plate</a:t>
+              <a:t>Continuity w/o plate (LEAD ONLY)</a:t>
             </a:r>
           </a:p>
         </p:txBody>
@@ -14921,7 +14879,271 @@
       </p:sp>
       <p:sp>
         <p:nvSpPr>
-          <p:cNvPr id="33" name="TextBox 32"/>
+          <p:cNvPr id="33" name="Rounded Rectangle 32"/>
+          <p:cNvSpPr/>
+          <p:nvPr/>
+        </p:nvSpPr>
+        <p:spPr>
+          <a:xfrm>
+            <a:off x="4279392" y="3337560"/>
+            <a:ext cx="3593592" cy="777240"/>
+          </a:xfrm>
+          <a:prstGeom prst="roundRect">
+            <a:avLst>
+              <a:gd name="adj" fmla="val 8000"/>
+            </a:avLst>
+          </a:prstGeom>
+          <a:solidFill>
+            <a:srgbClr val="F4F6FA"/>
+          </a:solidFill>
+          <a:ln>
+            <a:noFill/>
+          </a:ln>
+          <a:effectLst/>
+        </p:spPr>
+        <p:style>
+          <a:lnRef idx="1">
+            <a:schemeClr val="accent1"/>
+          </a:lnRef>
+          <a:fillRef idx="3">
+            <a:schemeClr val="accent1"/>
+          </a:fillRef>
+          <a:effectRef idx="2">
+            <a:schemeClr val="accent1"/>
+          </a:effectRef>
+          <a:fontRef idx="minor">
+            <a:schemeClr val="lt1"/>
+          </a:fontRef>
+        </p:style>
+        <p:txBody>
+          <a:bodyPr rtlCol="0" anchor="ctr"/>
+          <a:lstStyle/>
+          <a:p>
+            <a:pPr algn="ctr"/>
+          </a:p>
+        </p:txBody>
+      </p:sp>
+      <p:sp>
+        <p:nvSpPr>
+          <p:cNvPr id="34" name="Oval 33"/>
+          <p:cNvSpPr/>
+          <p:nvPr/>
+        </p:nvSpPr>
+        <p:spPr>
+          <a:xfrm>
+            <a:off x="4507992" y="3634740"/>
+            <a:ext cx="182880" cy="182880"/>
+          </a:xfrm>
+          <a:prstGeom prst="ellipse">
+            <a:avLst/>
+          </a:prstGeom>
+          <a:solidFill>
+            <a:srgbClr val="E04A4A"/>
+          </a:solidFill>
+          <a:ln>
+            <a:noFill/>
+          </a:ln>
+          <a:effectLst/>
+        </p:spPr>
+        <p:style>
+          <a:lnRef idx="1">
+            <a:schemeClr val="accent1"/>
+          </a:lnRef>
+          <a:fillRef idx="3">
+            <a:schemeClr val="accent1"/>
+          </a:fillRef>
+          <a:effectRef idx="2">
+            <a:schemeClr val="accent1"/>
+          </a:effectRef>
+          <a:fontRef idx="minor">
+            <a:schemeClr val="lt1"/>
+          </a:fontRef>
+        </p:style>
+        <p:txBody>
+          <a:bodyPr rtlCol="0" anchor="ctr"/>
+          <a:lstStyle/>
+          <a:p>
+            <a:pPr algn="ctr"/>
+          </a:p>
+        </p:txBody>
+      </p:sp>
+      <p:sp>
+        <p:nvSpPr>
+          <p:cNvPr id="35" name="TextBox 34"/>
+          <p:cNvSpPr txBox="1"/>
+          <p:nvPr/>
+        </p:nvSpPr>
+        <p:spPr>
+          <a:xfrm>
+            <a:off x="4828032" y="3337560"/>
+            <a:ext cx="2862072" cy="777240"/>
+          </a:xfrm>
+          <a:prstGeom prst="rect">
+            <a:avLst/>
+          </a:prstGeom>
+          <a:noFill/>
+        </p:spPr>
+        <p:txBody>
+          <a:bodyPr wrap="square" anchor="ctr" lIns="0" rIns="0" tIns="0" bIns="0">
+            <a:spAutoFit/>
+          </a:bodyPr>
+          <a:lstStyle/>
+          <a:p>
+            <a:pPr algn="l">
+              <a:lnSpc>
+                <a:spcPct val="110000"/>
+              </a:lnSpc>
+              <a:spcAft>
+                <a:spcPts val="0"/>
+              </a:spcAft>
+            </a:pPr>
+            <a:r>
+              <a:rPr sz="1300" b="1" i="0">
+                <a:solidFill>
+                  <a:srgbClr val="111827"/>
+                </a:solidFill>
+                <a:latin typeface="Segoe UI Semibold"/>
+              </a:rPr>
+              <a:t>§63-oriented evidence export</a:t>
+            </a:r>
+          </a:p>
+        </p:txBody>
+      </p:sp>
+      <p:sp>
+        <p:nvSpPr>
+          <p:cNvPr id="36" name="Rounded Rectangle 35"/>
+          <p:cNvSpPr/>
+          <p:nvPr/>
+        </p:nvSpPr>
+        <p:spPr>
+          <a:xfrm>
+            <a:off x="8010144" y="3337560"/>
+            <a:ext cx="3593592" cy="777240"/>
+          </a:xfrm>
+          <a:prstGeom prst="roundRect">
+            <a:avLst>
+              <a:gd name="adj" fmla="val 8000"/>
+            </a:avLst>
+          </a:prstGeom>
+          <a:solidFill>
+            <a:srgbClr val="F4F6FA"/>
+          </a:solidFill>
+          <a:ln>
+            <a:noFill/>
+          </a:ln>
+          <a:effectLst/>
+        </p:spPr>
+        <p:style>
+          <a:lnRef idx="1">
+            <a:schemeClr val="accent1"/>
+          </a:lnRef>
+          <a:fillRef idx="3">
+            <a:schemeClr val="accent1"/>
+          </a:fillRef>
+          <a:effectRef idx="2">
+            <a:schemeClr val="accent1"/>
+          </a:effectRef>
+          <a:fontRef idx="minor">
+            <a:schemeClr val="lt1"/>
+          </a:fontRef>
+        </p:style>
+        <p:txBody>
+          <a:bodyPr rtlCol="0" anchor="ctr"/>
+          <a:lstStyle/>
+          <a:p>
+            <a:pPr algn="ctr"/>
+          </a:p>
+        </p:txBody>
+      </p:sp>
+      <p:sp>
+        <p:nvSpPr>
+          <p:cNvPr id="37" name="Oval 36"/>
+          <p:cNvSpPr/>
+          <p:nvPr/>
+        </p:nvSpPr>
+        <p:spPr>
+          <a:xfrm>
+            <a:off x="8238744" y="3634740"/>
+            <a:ext cx="182880" cy="182880"/>
+          </a:xfrm>
+          <a:prstGeom prst="ellipse">
+            <a:avLst/>
+          </a:prstGeom>
+          <a:solidFill>
+            <a:srgbClr val="E04A4A"/>
+          </a:solidFill>
+          <a:ln>
+            <a:noFill/>
+          </a:ln>
+          <a:effectLst/>
+        </p:spPr>
+        <p:style>
+          <a:lnRef idx="1">
+            <a:schemeClr val="accent1"/>
+          </a:lnRef>
+          <a:fillRef idx="3">
+            <a:schemeClr val="accent1"/>
+          </a:fillRef>
+          <a:effectRef idx="2">
+            <a:schemeClr val="accent1"/>
+          </a:effectRef>
+          <a:fontRef idx="minor">
+            <a:schemeClr val="lt1"/>
+          </a:fontRef>
+        </p:style>
+        <p:txBody>
+          <a:bodyPr rtlCol="0" anchor="ctr"/>
+          <a:lstStyle/>
+          <a:p>
+            <a:pPr algn="ctr"/>
+          </a:p>
+        </p:txBody>
+      </p:sp>
+      <p:sp>
+        <p:nvSpPr>
+          <p:cNvPr id="38" name="TextBox 37"/>
+          <p:cNvSpPr txBox="1"/>
+          <p:nvPr/>
+        </p:nvSpPr>
+        <p:spPr>
+          <a:xfrm>
+            <a:off x="8558784" y="3337560"/>
+            <a:ext cx="2862072" cy="777240"/>
+          </a:xfrm>
+          <a:prstGeom prst="rect">
+            <a:avLst/>
+          </a:prstGeom>
+          <a:noFill/>
+        </p:spPr>
+        <p:txBody>
+          <a:bodyPr wrap="square" anchor="ctr" lIns="0" rIns="0" tIns="0" bIns="0">
+            <a:spAutoFit/>
+          </a:bodyPr>
+          <a:lstStyle/>
+          <a:p>
+            <a:pPr algn="l">
+              <a:lnSpc>
+                <a:spcPct val="110000"/>
+              </a:lnSpc>
+              <a:spcAft>
+                <a:spcPts val="0"/>
+              </a:spcAft>
+            </a:pPr>
+            <a:r>
+              <a:rPr sz="1300" b="1" i="0">
+                <a:solidFill>
+                  <a:srgbClr val="111827"/>
+                </a:solidFill>
+                <a:latin typeface="Segoe UI Semibold"/>
+              </a:rPr>
+              <a:t>Camera ANPR-suitability score</a:t>
+            </a:r>
+          </a:p>
+        </p:txBody>
+      </p:sp>
+      <p:sp>
+        <p:nvSpPr>
+          <p:cNvPr id="39" name="TextBox 38"/>
           <p:cNvSpPr txBox="1"/>
           <p:nvPr/>
         </p:nvSpPr>
@@ -15625,7 +15847,7 @@
                 </a:solidFill>
                 <a:latin typeface="Segoe UI Semilight"/>
               </a:rPr>
-              <a:t>See why a link was made</a:t>
+              <a:t>See why a link was made, and how weak</a:t>
             </a:r>
           </a:p>
           <a:p>
@@ -15653,7 +15875,7 @@
                 </a:solidFill>
                 <a:latin typeface="Segoe UI Semilight"/>
               </a:rPr>
-              <a:t>Defensible in court, not just demo</a:t>
+              <a:t>Provenance package for legal review — §63-oriented</a:t>
             </a:r>
           </a:p>
         </p:txBody>
@@ -16721,7 +16943,7 @@
                 </a:solidFill>
                 <a:latin typeface="Segoe UI"/>
               </a:rPr>
-              <a:t>Face recognition — deliberate exclusion</a:t>
+              <a:t>§63 evidence certificate export — not yet built</a:t>
             </a:r>
           </a:p>
         </p:txBody>
@@ -16853,7 +17075,7 @@
                 </a:solidFill>
                 <a:latin typeface="Segoe UI"/>
               </a:rPr>
-              <a:t>Full 80k-camera physical ingestion</a:t>
+              <a:t>Camera ANPR-suitability scoring — not yet built</a:t>
             </a:r>
           </a:p>
         </p:txBody>
@@ -16985,7 +17207,7 @@
                 </a:solidFill>
                 <a:latin typeface="Segoe UI"/>
               </a:rPr>
-              <a:t>Real VMS federation middleware</a:t>
+              <a:t>Face recognition — deliberate exclusion</a:t>
             </a:r>
           </a:p>
         </p:txBody>
@@ -17117,7 +17339,7 @@
                 </a:solidFill>
                 <a:latin typeface="Segoe UI"/>
               </a:rPr>
-              <a:t>WHEP low-latency preview</a:t>
+              <a:t>Full 80k-camera physical ingestion</a:t>
             </a:r>
           </a:p>
         </p:txBody>
@@ -17249,7 +17471,7 @@
                 </a:solidFill>
                 <a:latin typeface="Segoe UI"/>
               </a:rPr>
-              <a:t>Two-line-plate consensus voting</a:t>
+              <a:t>Live ONVIF device validated — mocked-tests only</a:t>
             </a:r>
           </a:p>
         </p:txBody>
@@ -17381,7 +17603,7 @@
                 </a:solidFill>
                 <a:latin typeface="Segoe UI"/>
               </a:rPr>
-              <a:t>Coverage-radius GIS map layer</a:t>
+              <a:t>WHEP low-latency preview</a:t>
             </a:r>
           </a:p>
         </p:txBody>
@@ -17513,7 +17735,7 @@
                 </a:solidFill>
                 <a:latin typeface="Segoe UI"/>
               </a:rPr>
-              <a:t>Indian-specific detector — evaluated</a:t>
+              <a:t>Appearance-Re-ID accuracy — measured, not fixed</a:t>
             </a:r>
           </a:p>
         </p:txBody>
@@ -18409,7 +18631,7 @@
                 </a:solidFill>
                 <a:latin typeface="Segoe UI Semibold"/>
               </a:rPr>
-              <a:t>VISWAS / NETRAM / TRINETRA scale (7,000+ cameras, 34 district centres)</a:t>
+              <a:t>Only 3.8% of ANPR-detected violations reach enforcement</a:t>
             </a:r>
           </a:p>
         </p:txBody>
@@ -18451,7 +18673,7 @@
                 </a:solidFill>
                 <a:latin typeface="Segoe UI Semilight"/>
               </a:rPr>
-              <a:t>Gujarat Home Dept. public statements</a:t>
+              <a:t>CAG audit, 2025</a:t>
             </a:r>
           </a:p>
         </p:txBody>
@@ -18583,7 +18805,7 @@
                 </a:solidFill>
                 <a:latin typeface="Segoe UI Semibold"/>
               </a:rPr>
-              <a:t>Commercial ANPR/tracking precedent</a:t>
+              <a:t>Appearance-link false-positive rate (41.87%), measured on real sandbox data</a:t>
             </a:r>
           </a:p>
         </p:txBody>
@@ -18625,7 +18847,7 @@
                 </a:solidFill>
                 <a:latin typeface="Segoe UI Semilight"/>
               </a:rPr>
-              <a:t>Staqu JARVIS, Videonetics, Vehant, Innefu</a:t>
+              <a:t>calibrate_embedding_threshold.py, project test</a:t>
             </a:r>
           </a:p>
         </p:txBody>
@@ -18757,7 +18979,7 @@
                 </a:solidFill>
                 <a:latin typeface="Segoe UI Semibold"/>
               </a:rPr>
-              <a:t>Field ANPR accuracy vs. lab benchmarks (71% misread rate cited)</a:t>
+              <a:t>VISWAS / NETRAM / TRINETRA scale (7,000+ cameras, 34 district centres)</a:t>
             </a:r>
           </a:p>
         </p:txBody>
@@ -18799,7 +19021,7 @@
                 </a:solidFill>
                 <a:latin typeface="Segoe UI Semilight"/>
               </a:rPr>
-              <a:t>Business Insider / Gizmodo, Aug 2026; Davis Vanguard, Aug 2026</a:t>
+              <a:t>Gujarat Home Dept. public statements</a:t>
             </a:r>
           </a:p>
         </p:txBody>
@@ -18931,7 +19153,7 @@
                 </a:solidFill>
                 <a:latin typeface="Segoe UI Semibold"/>
               </a:rPr>
-              <a:t>Indian-traffic detector benchmark, evaluated not integrated</a:t>
+              <a:t>Commercial ANPR/tracking precedent</a:t>
             </a:r>
           </a:p>
         </p:txBody>
@@ -18973,7 +19195,7 @@
                 </a:solidFill>
                 <a:latin typeface="Segoe UI Semilight"/>
               </a:rPr>
-              <a:t>IISc AI for Integrated Mobility — UVH-26, arXiv 2511.02563</a:t>
+              <a:t>Staqu JARVIS, Videonetics, Vehant, Innefu</a:t>
             </a:r>
           </a:p>
         </p:txBody>
@@ -19105,7 +19327,7 @@
                 </a:solidFill>
                 <a:latin typeface="Segoe UI Semibold"/>
               </a:rPr>
-              <a:t>Data-protection design posture</a:t>
+              <a:t>Field ANPR accuracy vs. lab benchmarks (71% misread rate cited)</a:t>
             </a:r>
           </a:p>
         </p:txBody>
@@ -19147,7 +19369,7 @@
                 </a:solidFill>
                 <a:latin typeface="Segoe UI Semilight"/>
               </a:rPr>
-              <a:t>Digital Personal Data Protection Act, 2023 — Section 17</a:t>
+              <a:t>Business Insider / Gizmodo, Aug 2026; Davis Vanguard, Aug 2026</a:t>
             </a:r>
           </a:p>
         </p:txBody>
@@ -19279,7 +19501,7 @@
                 </a:solidFill>
                 <a:latin typeface="Segoe UI Semibold"/>
               </a:rPr>
-              <a:t>UK National ANPR retention precedent</a:t>
+              <a:t>Indian-traffic detector benchmark, evaluated not integrated</a:t>
             </a:r>
           </a:p>
         </p:txBody>
@@ -19321,6 +19543,354 @@
                 </a:solidFill>
                 <a:latin typeface="Segoe UI Semilight"/>
               </a:rPr>
+              <a:t>IISc AI for Integrated Mobility — UVH-26, arXiv 2511.02563</a:t>
+            </a:r>
+          </a:p>
+        </p:txBody>
+      </p:sp>
+      <p:sp>
+        <p:nvSpPr>
+          <p:cNvPr id="40" name="Rounded Rectangle 39"/>
+          <p:cNvSpPr/>
+          <p:nvPr/>
+        </p:nvSpPr>
+        <p:spPr>
+          <a:xfrm>
+            <a:off x="548640" y="6163056"/>
+            <a:ext cx="11064240" cy="566928"/>
+          </a:xfrm>
+          <a:prstGeom prst="roundRect">
+            <a:avLst>
+              <a:gd name="adj" fmla="val 8000"/>
+            </a:avLst>
+          </a:prstGeom>
+          <a:solidFill>
+            <a:srgbClr val="F4F6FA"/>
+          </a:solidFill>
+          <a:ln>
+            <a:noFill/>
+          </a:ln>
+          <a:effectLst/>
+        </p:spPr>
+        <p:style>
+          <a:lnRef idx="1">
+            <a:schemeClr val="accent1"/>
+          </a:lnRef>
+          <a:fillRef idx="3">
+            <a:schemeClr val="accent1"/>
+          </a:fillRef>
+          <a:effectRef idx="2">
+            <a:schemeClr val="accent1"/>
+          </a:effectRef>
+          <a:fontRef idx="minor">
+            <a:schemeClr val="lt1"/>
+          </a:fontRef>
+        </p:style>
+        <p:txBody>
+          <a:bodyPr rtlCol="0" anchor="ctr"/>
+          <a:lstStyle/>
+          <a:p>
+            <a:pPr algn="ctr"/>
+          </a:p>
+        </p:txBody>
+      </p:sp>
+      <p:sp>
+        <p:nvSpPr>
+          <p:cNvPr id="41" name="Rectangle 40"/>
+          <p:cNvSpPr/>
+          <p:nvPr/>
+        </p:nvSpPr>
+        <p:spPr>
+          <a:xfrm>
+            <a:off x="548640" y="6163056"/>
+            <a:ext cx="64008" cy="566928"/>
+          </a:xfrm>
+          <a:prstGeom prst="rect">
+            <a:avLst/>
+          </a:prstGeom>
+          <a:solidFill>
+            <a:srgbClr val="2F7AF2"/>
+          </a:solidFill>
+          <a:ln>
+            <a:noFill/>
+          </a:ln>
+          <a:effectLst/>
+        </p:spPr>
+        <p:style>
+          <a:lnRef idx="1">
+            <a:schemeClr val="accent1"/>
+          </a:lnRef>
+          <a:fillRef idx="3">
+            <a:schemeClr val="accent1"/>
+          </a:fillRef>
+          <a:effectRef idx="2">
+            <a:schemeClr val="accent1"/>
+          </a:effectRef>
+          <a:fontRef idx="minor">
+            <a:schemeClr val="lt1"/>
+          </a:fontRef>
+        </p:style>
+        <p:txBody>
+          <a:bodyPr rtlCol="0" anchor="ctr"/>
+          <a:lstStyle/>
+          <a:p>
+            <a:pPr algn="ctr"/>
+          </a:p>
+        </p:txBody>
+      </p:sp>
+      <p:sp>
+        <p:nvSpPr>
+          <p:cNvPr id="42" name="TextBox 41"/>
+          <p:cNvSpPr txBox="1"/>
+          <p:nvPr/>
+        </p:nvSpPr>
+        <p:spPr>
+          <a:xfrm>
+            <a:off x="777240" y="6236208"/>
+            <a:ext cx="6949440" cy="438912"/>
+          </a:xfrm>
+          <a:prstGeom prst="rect">
+            <a:avLst/>
+          </a:prstGeom>
+          <a:noFill/>
+        </p:spPr>
+        <p:txBody>
+          <a:bodyPr wrap="square" anchor="ctr" lIns="0" rIns="0" tIns="0" bIns="0">
+            <a:spAutoFit/>
+          </a:bodyPr>
+          <a:lstStyle/>
+          <a:p>
+            <a:pPr algn="l">
+              <a:lnSpc>
+                <a:spcPct val="105000"/>
+              </a:lnSpc>
+              <a:spcAft>
+                <a:spcPts val="0"/>
+              </a:spcAft>
+            </a:pPr>
+            <a:r>
+              <a:rPr sz="1250" b="1" i="0">
+                <a:solidFill>
+                  <a:srgbClr val="111827"/>
+                </a:solidFill>
+                <a:latin typeface="Segoe UI Semibold"/>
+              </a:rPr>
+              <a:t>Data-protection design posture</a:t>
+            </a:r>
+          </a:p>
+        </p:txBody>
+      </p:sp>
+      <p:sp>
+        <p:nvSpPr>
+          <p:cNvPr id="43" name="TextBox 42"/>
+          <p:cNvSpPr txBox="1"/>
+          <p:nvPr/>
+        </p:nvSpPr>
+        <p:spPr>
+          <a:xfrm>
+            <a:off x="7818120" y="6236208"/>
+            <a:ext cx="3657600" cy="438912"/>
+          </a:xfrm>
+          <a:prstGeom prst="rect">
+            <a:avLst/>
+          </a:prstGeom>
+          <a:noFill/>
+        </p:spPr>
+        <p:txBody>
+          <a:bodyPr wrap="square" anchor="ctr" lIns="0" rIns="0" tIns="0" bIns="0">
+            <a:spAutoFit/>
+          </a:bodyPr>
+          <a:lstStyle/>
+          <a:p>
+            <a:pPr algn="r">
+              <a:lnSpc>
+                <a:spcPct val="105000"/>
+              </a:lnSpc>
+              <a:spcAft>
+                <a:spcPts val="0"/>
+              </a:spcAft>
+            </a:pPr>
+            <a:r>
+              <a:rPr sz="1100" b="0" i="1">
+                <a:solidFill>
+                  <a:srgbClr val="616E82"/>
+                </a:solidFill>
+                <a:latin typeface="Segoe UI Semilight"/>
+              </a:rPr>
+              <a:t>Digital Personal Data Protection Act, 2023 — Section 17</a:t>
+            </a:r>
+          </a:p>
+        </p:txBody>
+      </p:sp>
+      <p:sp>
+        <p:nvSpPr>
+          <p:cNvPr id="44" name="Rounded Rectangle 43"/>
+          <p:cNvSpPr/>
+          <p:nvPr/>
+        </p:nvSpPr>
+        <p:spPr>
+          <a:xfrm>
+            <a:off x="548640" y="6821424"/>
+            <a:ext cx="11064240" cy="566928"/>
+          </a:xfrm>
+          <a:prstGeom prst="roundRect">
+            <a:avLst>
+              <a:gd name="adj" fmla="val 8000"/>
+            </a:avLst>
+          </a:prstGeom>
+          <a:solidFill>
+            <a:srgbClr val="F4F6FA"/>
+          </a:solidFill>
+          <a:ln>
+            <a:noFill/>
+          </a:ln>
+          <a:effectLst/>
+        </p:spPr>
+        <p:style>
+          <a:lnRef idx="1">
+            <a:schemeClr val="accent1"/>
+          </a:lnRef>
+          <a:fillRef idx="3">
+            <a:schemeClr val="accent1"/>
+          </a:fillRef>
+          <a:effectRef idx="2">
+            <a:schemeClr val="accent1"/>
+          </a:effectRef>
+          <a:fontRef idx="minor">
+            <a:schemeClr val="lt1"/>
+          </a:fontRef>
+        </p:style>
+        <p:txBody>
+          <a:bodyPr rtlCol="0" anchor="ctr"/>
+          <a:lstStyle/>
+          <a:p>
+            <a:pPr algn="ctr"/>
+          </a:p>
+        </p:txBody>
+      </p:sp>
+      <p:sp>
+        <p:nvSpPr>
+          <p:cNvPr id="45" name="Rectangle 44"/>
+          <p:cNvSpPr/>
+          <p:nvPr/>
+        </p:nvSpPr>
+        <p:spPr>
+          <a:xfrm>
+            <a:off x="548640" y="6821424"/>
+            <a:ext cx="64008" cy="566928"/>
+          </a:xfrm>
+          <a:prstGeom prst="rect">
+            <a:avLst/>
+          </a:prstGeom>
+          <a:solidFill>
+            <a:srgbClr val="2F7AF2"/>
+          </a:solidFill>
+          <a:ln>
+            <a:noFill/>
+          </a:ln>
+          <a:effectLst/>
+        </p:spPr>
+        <p:style>
+          <a:lnRef idx="1">
+            <a:schemeClr val="accent1"/>
+          </a:lnRef>
+          <a:fillRef idx="3">
+            <a:schemeClr val="accent1"/>
+          </a:fillRef>
+          <a:effectRef idx="2">
+            <a:schemeClr val="accent1"/>
+          </a:effectRef>
+          <a:fontRef idx="minor">
+            <a:schemeClr val="lt1"/>
+          </a:fontRef>
+        </p:style>
+        <p:txBody>
+          <a:bodyPr rtlCol="0" anchor="ctr"/>
+          <a:lstStyle/>
+          <a:p>
+            <a:pPr algn="ctr"/>
+          </a:p>
+        </p:txBody>
+      </p:sp>
+      <p:sp>
+        <p:nvSpPr>
+          <p:cNvPr id="46" name="TextBox 45"/>
+          <p:cNvSpPr txBox="1"/>
+          <p:nvPr/>
+        </p:nvSpPr>
+        <p:spPr>
+          <a:xfrm>
+            <a:off x="777240" y="6894576"/>
+            <a:ext cx="6949440" cy="438912"/>
+          </a:xfrm>
+          <a:prstGeom prst="rect">
+            <a:avLst/>
+          </a:prstGeom>
+          <a:noFill/>
+        </p:spPr>
+        <p:txBody>
+          <a:bodyPr wrap="square" anchor="ctr" lIns="0" rIns="0" tIns="0" bIns="0">
+            <a:spAutoFit/>
+          </a:bodyPr>
+          <a:lstStyle/>
+          <a:p>
+            <a:pPr algn="l">
+              <a:lnSpc>
+                <a:spcPct val="105000"/>
+              </a:lnSpc>
+              <a:spcAft>
+                <a:spcPts val="0"/>
+              </a:spcAft>
+            </a:pPr>
+            <a:r>
+              <a:rPr sz="1250" b="1" i="0">
+                <a:solidFill>
+                  <a:srgbClr val="111827"/>
+                </a:solidFill>
+                <a:latin typeface="Segoe UI Semibold"/>
+              </a:rPr>
+              <a:t>UK National ANPR retention precedent</a:t>
+            </a:r>
+          </a:p>
+        </p:txBody>
+      </p:sp>
+      <p:sp>
+        <p:nvSpPr>
+          <p:cNvPr id="47" name="TextBox 46"/>
+          <p:cNvSpPr txBox="1"/>
+          <p:nvPr/>
+        </p:nvSpPr>
+        <p:spPr>
+          <a:xfrm>
+            <a:off x="7818120" y="6894576"/>
+            <a:ext cx="3657600" cy="438912"/>
+          </a:xfrm>
+          <a:prstGeom prst="rect">
+            <a:avLst/>
+          </a:prstGeom>
+          <a:noFill/>
+        </p:spPr>
+        <p:txBody>
+          <a:bodyPr wrap="square" anchor="ctr" lIns="0" rIns="0" tIns="0" bIns="0">
+            <a:spAutoFit/>
+          </a:bodyPr>
+          <a:lstStyle/>
+          <a:p>
+            <a:pPr algn="r">
+              <a:lnSpc>
+                <a:spcPct val="105000"/>
+              </a:lnSpc>
+              <a:spcAft>
+                <a:spcPts val="0"/>
+              </a:spcAft>
+            </a:pPr>
+            <a:r>
+              <a:rPr sz="1100" b="0" i="1">
+                <a:solidFill>
+                  <a:srgbClr val="616E82"/>
+                </a:solidFill>
+                <a:latin typeface="Segoe UI Semilight"/>
+              </a:rPr>
               <a:t>cited in RESEARCH_EXISTING_SYSTEMS.md §6</a:t>
             </a:r>
           </a:p>
@@ -19328,13 +19898,13 @@
       </p:sp>
       <p:sp>
         <p:nvSpPr>
-          <p:cNvPr id="40" name="TextBox 39"/>
+          <p:cNvPr id="48" name="TextBox 47"/>
           <p:cNvSpPr txBox="1"/>
           <p:nvPr/>
         </p:nvSpPr>
         <p:spPr>
           <a:xfrm>
-            <a:off x="548640" y="6236208"/>
+            <a:off x="548640" y="7552944"/>
             <a:ext cx="11064240" cy="365760"/>
           </a:xfrm>
           <a:prstGeom prst="rect">
@@ -19995,7 +20565,7 @@
                 </a:solidFill>
                 <a:latin typeface="Segoe UI Semibold"/>
               </a:rPr>
-              <a:t>The problem</a:t>
+              <a:t>The real problem</a:t>
             </a:r>
           </a:p>
         </p:txBody>
@@ -20865,7 +21435,7 @@
                 </a:solidFill>
                 <a:latin typeface="Segoe UI Semibold"/>
               </a:rPr>
-              <a:t>ANPR failure ≠ tracking failure</a:t>
+              <a:t>Evidence tiers, measured</a:t>
             </a:r>
           </a:p>
         </p:txBody>
@@ -21039,7 +21609,7 @@
                 </a:solidFill>
                 <a:latin typeface="Segoe UI Semibold"/>
               </a:rPr>
-              <a:t>Geo-temporal routing</a:t>
+              <a:t>Governed cross-camera linking</a:t>
             </a:r>
           </a:p>
         </p:txBody>
@@ -22893,13 +23463,13 @@
               </a:spcAft>
             </a:pPr>
             <a:r>
-              <a:rPr sz="1650" b="0" i="0">
+              <a:rPr sz="1600" b="0" i="0">
                 <a:solidFill>
                   <a:srgbClr val="B9C6DA"/>
                 </a:solidFill>
                 <a:latin typeface="Segoe UI Semilight"/>
               </a:rPr>
-              <a:t>An honest, verified, open-source layer — built to extend Gujarat's CCTV infrastructure, not replace it.</a:t>
+              <a:t>Gujarat already has the eyes and the detectors. Sentinel makes what they see explainable, auditable, and evidence-ready.</a:t>
             </a:r>
           </a:p>
         </p:txBody>
@@ -22978,7 +23548,7 @@
                 </a:solidFill>
                 <a:latin typeface="Segoe UI Semilight"/>
               </a:rPr>
-              <a:t>Own-feed and government-feed demo videos per §9.3/§9.4</a:t>
+              <a:t>Own-feed demo video per §9.3, real sandbox footage</a:t>
             </a:r>
           </a:p>
           <a:p>
@@ -23006,7 +23576,7 @@
                 </a:solidFill>
                 <a:latin typeface="Segoe UI Semilight"/>
               </a:rPr>
-              <a:t>Every claim traces to verified, runnable code</a:t>
+              <a:t>Every claim on this deck traces to verified, runnable code or a stated gap</a:t>
             </a:r>
           </a:p>
         </p:txBody>
@@ -23380,7 +23950,7 @@
                 </a:solidFill>
                 <a:latin typeface="Segoe UI Semibold"/>
               </a:rPr>
-              <a:t>THE CHALLENGE</a:t>
+              <a:t>THE REAL PROBLEM</a:t>
             </a:r>
           </a:p>
         </p:txBody>
@@ -23416,13 +23986,13 @@
               </a:spcAft>
             </a:pPr>
             <a:r>
-              <a:rPr sz="3000" b="1" i="0">
+              <a:rPr sz="2500" b="1" i="0">
                 <a:solidFill>
                   <a:srgbClr val="FFFFFF"/>
                 </a:solidFill>
                 <a:latin typeface="Bahnschrift SemiBold"/>
               </a:rPr>
-              <a:t>26 departments. No shared intelligence layer.</a:t>
+              <a:t>Gujarat has the cameras and the ANPR. It's an integration and evidence problem.</a:t>
             </a:r>
           </a:p>
         </p:txBody>
@@ -23594,7 +24164,7 @@
                 </a:solidFill>
                 <a:latin typeface="Bahnschrift SemiBold"/>
               </a:rPr>
-              <a:t>26</a:t>
+              <a:t>7,078</a:t>
             </a:r>
           </a:p>
         </p:txBody>
@@ -23636,7 +24206,7 @@
                 </a:solidFill>
                 <a:latin typeface="Segoe UI"/>
               </a:rPr>
-              <a:t>Departments,</a:t>
+              <a:t>Cameras already live under</a:t>
             </a:r>
           </a:p>
           <a:p>
@@ -23655,7 +24225,7 @@
                 </a:solidFill>
                 <a:latin typeface="Segoe UI"/>
               </a:rPr>
-              <a:t>independent systems</a:t>
+              <a:t>VISWAS / NETRAM / TRINETRA</a:t>
             </a:r>
           </a:p>
         </p:txBody>
@@ -23743,7 +24313,7 @@
                 </a:solidFill>
                 <a:latin typeface="Bahnschrift SemiBold"/>
               </a:rPr>
-              <a:t>~80,000</a:t>
+              <a:t>3.8%</a:t>
             </a:r>
           </a:p>
         </p:txBody>
@@ -23785,7 +24355,26 @@
                 </a:solidFill>
                 <a:latin typeface="Segoe UI"/>
               </a:rPr>
-              <a:t>Cameras statewide</a:t>
+              <a:t>of ANPR-detected violations</a:t>
+            </a:r>
+          </a:p>
+          <a:p>
+            <a:pPr algn="ctr">
+              <a:lnSpc>
+                <a:spcPct val="115000"/>
+              </a:lnSpc>
+              <a:spcAft>
+                <a:spcPts val="0"/>
+              </a:spcAft>
+            </a:pPr>
+            <a:r>
+              <a:rPr sz="1200" b="0" i="0">
+                <a:solidFill>
+                  <a:srgbClr val="C7D3E3"/>
+                </a:solidFill>
+                <a:latin typeface="Segoe UI"/>
+              </a:rPr>
+              <a:t>reach enforcement — CAG 2025</a:t>
             </a:r>
           </a:p>
         </p:txBody>
@@ -23873,7 +24462,7 @@
                 </a:solidFill>
                 <a:latin typeface="Bahnschrift SemiBold"/>
               </a:rPr>
-              <a:t>7–15+</a:t>
+              <a:t>26</a:t>
             </a:r>
           </a:p>
         </p:txBody>
@@ -23915,7 +24504,7 @@
                 </a:solidFill>
                 <a:latin typeface="Segoe UI"/>
               </a:rPr>
-              <a:t>Days retention,</a:t>
+              <a:t>Departments,</a:t>
             </a:r>
           </a:p>
           <a:p>
@@ -23934,7 +24523,7 @@
                 </a:solidFill>
                 <a:latin typeface="Segoe UI"/>
               </a:rPr>
-              <a:t>varies by department</a:t>
+              <a:t>independent systems</a:t>
             </a:r>
           </a:p>
         </p:txBody>
@@ -24064,7 +24653,7 @@
                 </a:solidFill>
                 <a:latin typeface="Segoe UI"/>
               </a:rPr>
-              <a:t>Unified cross-reference</a:t>
+              <a:t>Systems today that explain</a:t>
             </a:r>
           </a:p>
           <a:p>
@@ -24083,7 +24672,7 @@
                 </a:solidFill>
                 <a:latin typeface="Segoe UI"/>
               </a:rPr>
-              <a:t>today</a:t>
+              <a:t>why a cross-camera link was made</a:t>
             </a:r>
           </a:p>
         </p:txBody>
@@ -24949,7 +25538,7 @@
                 </a:solidFill>
                 <a:latin typeface="Bahnschrift SemiBold"/>
               </a:rPr>
-              <a:t>We extend what exists — we don't replace it</a:t>
+              <a:t>The accountability layer — not another vehicle-tracking AI</a:t>
             </a:r>
           </a:p>
         </p:txBody>
@@ -25157,7 +25746,7 @@
               </a:spcAft>
             </a:pPr>
             <a:r>
-              <a:rPr sz="1400" b="1">
+              <a:rPr sz="1350" b="1">
                 <a:solidFill>
                   <a:srgbClr val="E04A4A"/>
                 </a:solidFill>
@@ -25166,13 +25755,13 @@
               <a:t>—  </a:t>
             </a:r>
             <a:r>
-              <a:rPr sz="1400">
+              <a:rPr sz="1350">
                 <a:solidFill>
                   <a:srgbClr val="EEC9C9"/>
                 </a:solidFill>
                 <a:latin typeface="Segoe UI"/>
               </a:rPr>
-              <a:t>“We built Gujarat's CCTV platform”</a:t>
+              <a:t>“An AI that tracks vehicles across cameras even when the plate is unreadable”</a:t>
             </a:r>
           </a:p>
           <a:p>
@@ -25185,7 +25774,7 @@
               </a:spcAft>
             </a:pPr>
             <a:r>
-              <a:rPr sz="1400" b="1">
+              <a:rPr sz="1350" b="1">
                 <a:solidFill>
                   <a:srgbClr val="E04A4A"/>
                 </a:solidFill>
@@ -25194,13 +25783,13 @@
               <a:t>—  </a:t>
             </a:r>
             <a:r>
-              <a:rPr sz="1400">
+              <a:rPr sz="1350">
                 <a:solidFill>
                   <a:srgbClr val="EEC9C9"/>
                 </a:solidFill>
                 <a:latin typeface="Segoe UI"/>
               </a:rPr>
-              <a:t>Inventing ANPR or cross-camera tracking (already Staqu, Videonetics, Vehant)</a:t>
+              <a:t>Inventing ANPR or cross-camera tracking (already Staqu, Videonetics, Vehant, BriefCam)</a:t>
             </a:r>
           </a:p>
         </p:txBody>
@@ -25324,7 +25913,7 @@
               </a:spcAft>
             </a:pPr>
             <a:r>
-              <a:rPr sz="1400" b="1">
+              <a:rPr sz="1350" b="1">
                 <a:solidFill>
                   <a:srgbClr val="1EC9B7"/>
                 </a:solidFill>
@@ -25333,13 +25922,13 @@
               <a:t>—  </a:t>
             </a:r>
             <a:r>
-              <a:rPr sz="1400">
+              <a:rPr sz="1350">
                 <a:solidFill>
                   <a:srgbClr val="C9E9DE"/>
                 </a:solidFill>
                 <a:latin typeface="Segoe UI"/>
               </a:rPr>
-              <a:t>An intelligence layer above VISWAS / TRINETRA / NETRAM</a:t>
+              <a:t>An open, vendor-neutral layer over VISWAS / TRINETRA / NETRAM</a:t>
             </a:r>
           </a:p>
           <a:p>
@@ -25352,7 +25941,7 @@
               </a:spcAft>
             </a:pPr>
             <a:r>
-              <a:rPr sz="1400" b="1">
+              <a:rPr sz="1350" b="1">
                 <a:solidFill>
                   <a:srgbClr val="1EC9B7"/>
                 </a:solidFill>
@@ -25361,13 +25950,13 @@
               <a:t>—  </a:t>
             </a:r>
             <a:r>
-              <a:rPr sz="1400">
+              <a:rPr sz="1350">
                 <a:solidFill>
                   <a:srgbClr val="C9E9DE"/>
                 </a:solidFill>
                 <a:latin typeface="Segoe UI"/>
               </a:rPr>
-              <a:t>A genuinely open, explainable identity-resolution layer</a:t>
+              <a:t>Makes every cross-camera inference explainable, every query purpose-bound, every camera's ANPR fitness measurable</a:t>
             </a:r>
           </a:p>
         </p:txBody>
@@ -25403,13 +25992,13 @@
               </a:spcAft>
             </a:pPr>
             <a:r>
-              <a:rPr sz="1500" b="0" i="0">
+              <a:rPr sz="1400" b="0" i="0">
                 <a:solidFill>
                   <a:srgbClr val="616E82"/>
                 </a:solidFill>
                 <a:latin typeface="Segoe UI Semilight"/>
               </a:rPr>
-              <a:t>Gujarat already runs VISWAS/NETRAM/TRINETRA at 7,000+ cameras across 34 district centres. A jury with that knowledge asks “what did you invent?” — honesty here is the stronger pitch, and it is exactly what the bonus criterion for “innovative hybrid architecture” rewards.</a:t>
+              <a:t>Gujarat already runs VISWAS/NETRAM/TRINETRA at 7,000+ cameras. CAG's own 2025 audit found the gap is integration and evidentiary usability, not detection — only 3.8% of ANPR-detected violations reach enforcement. A jury with that knowledge asks “what did you invent?” — honesty about what is and isn't proven is the stronger pitch here, not a bigger tracking claim.</a:t>
             </a:r>
           </a:p>
         </p:txBody>
@@ -25783,7 +26372,7 @@
                 </a:solidFill>
                 <a:latin typeface="Bahnschrift SemiBold"/>
               </a:rPr>
-              <a:t>Model 1 + Model 2 — with a documented roadmap</a:t>
+              <a:t>Model 1 + Model 2 + Model 3 — a real hybrid, built and tested</a:t>
             </a:r>
           </a:p>
         </p:txBody>
@@ -26321,7 +26910,7 @@
             </a:avLst>
           </a:prstGeom>
           <a:solidFill>
-            <a:srgbClr val="F4F6FA"/>
+            <a:srgbClr val="0D1628"/>
           </a:solidFill>
           <a:ln>
             <a:noFill/>
@@ -26383,7 +26972,7 @@
             <a:r>
               <a:rPr sz="4400" b="1" i="0">
                 <a:solidFill>
-                  <a:srgbClr val="EAEEF5"/>
+                  <a:srgbClr val="2F7AF2"/>
                 </a:solidFill>
                 <a:latin typeface="Bahnschrift SemiBold"/>
               </a:rPr>
@@ -26407,7 +26996,7 @@
             <a:avLst/>
           </a:prstGeom>
           <a:solidFill>
-            <a:srgbClr val="8A93A3"/>
+            <a:srgbClr val="12A16B"/>
           </a:solidFill>
           <a:ln>
             <a:noFill/>
@@ -26469,11 +27058,11 @@
             <a:r>
               <a:rPr sz="1900" b="1" i="0">
                 <a:solidFill>
-                  <a:srgbClr val="111827"/>
+                  <a:srgbClr val="FFFFFF"/>
                 </a:solidFill>
                 <a:latin typeface="Segoe UI Semibold"/>
               </a:rPr>
-              <a:t>Federation → Central AI</a:t>
+              <a:t>VMS Federation</a:t>
             </a:r>
           </a:p>
         </p:txBody>
@@ -26511,11 +27100,11 @@
             <a:r>
               <a:rPr sz="1300" b="0" i="0">
                 <a:solidFill>
-                  <a:srgbClr val="616E82"/>
+                  <a:srgbClr val="B9C6DA"/>
                 </a:solidFill>
                 <a:latin typeface="Segoe UI Semilight"/>
               </a:rPr>
-              <a:t>Documented roadmap</a:t>
+              <a:t>Built &amp; tested — Sentinel + NYC Open Data</a:t>
             </a:r>
           </a:p>
         </p:txBody>
@@ -26551,13 +27140,13 @@
               </a:spcAft>
             </a:pPr>
             <a:r>
-              <a:rPr sz="1450" b="0" i="0">
+              <a:rPr sz="1350" b="0" i="0">
                 <a:solidFill>
                   <a:srgbClr val="616E82"/>
                 </a:solidFill>
                 <a:latin typeface="Segoe UI Semilight"/>
               </a:rPr>
-              <a:t>“Combine two or more models” is the problem statement's own definition of a hybrid — we claim credit only for what is built and verified; Model 3/4 stays a documented roadmap.</a:t>
+              <a:t>“Combine two or more models” is the problem statement's own definition of a hybrid — we claim credit only for what is built and verified. Model 3 federates our own data with a second, real, independently-operated public dataset (not a second Gujarat system); Model 4 (state-level central VMS/command centre) stays a documented roadmap, not built this cycle.</a:t>
             </a:r>
           </a:p>
         </p:txBody>
@@ -27057,7 +27646,7 @@
                 </a:solidFill>
                 <a:latin typeface="Segoe UI Semilight"/>
               </a:rPr>
-              <a:t>A persistent vehicle identity built from uncertain evidence — every cross-camera link explains itself.</a:t>
+              <a:t>Not a stronger tracking claim — a governance layer that refuses to let inference pass as fact.</a:t>
             </a:r>
           </a:p>
         </p:txBody>
@@ -27231,7 +27820,7 @@
                 </a:solidFill>
                 <a:latin typeface="Segoe UI Semibold"/>
               </a:rPr>
-              <a:t>ANPR ≠ tracking failure</a:t>
+              <a:t>Evidence tiers, enforced</a:t>
             </a:r>
           </a:p>
         </p:txBody>
@@ -27273,7 +27862,7 @@
                 </a:solidFill>
                 <a:latin typeface="Segoe UI Semilight"/>
               </a:rPr>
-              <a:t>Unreadable plate still tracked by appearance; upgraded the moment any camera reads it.</a:t>
+              <a:t>CONFIRMED / PROBABLE / LEAD ONLY — a LEAD ONLY link can never be exported as evidence.</a:t>
             </a:r>
           </a:p>
         </p:txBody>
@@ -27921,7 +28510,7 @@
                 </a:solidFill>
                 <a:latin typeface="Segoe UI Semilight"/>
               </a:rPr>
-              <a:t>Every match shows its score — a transparency aid, not a black box.</a:t>
+              <a:t>Every match shows its method and score, including when that score is weak.</a:t>
             </a:r>
           </a:p>
         </p:txBody>
@@ -33020,13 +33609,13 @@
               </a:spcAft>
             </a:pPr>
             <a:r>
-              <a:rPr sz="1350" b="1" i="0">
+              <a:rPr sz="1300" b="1" i="0">
                 <a:solidFill>
                   <a:srgbClr val="12A16B"/>
                 </a:solidFill>
                 <a:latin typeface="Segoe UI Semilight"/>
               </a:rPr>
-              <a:t>Real-footage result: a real sandbox vehicle's plate (GJ01RP6128) read correctly and confidently, verified through the actual production accept-logic — not a lab condition.</a:t>
+              <a:t>Real-footage result: a real sandbox vehicle's plate (GJ01RP6128) read correctly and confidently on camera cam06, verified through the actual production accept-logic. A single-camera read, stated as exactly that — not evidence of cross-camera tracking.</a:t>
             </a:r>
           </a:p>
         </p:txBody>

</xml_diff>